<commit_message>
Add NKUA / MSc DSIT affiliation and supervisor to report, slides and README
Co-Authored-By: Claude Opus 4.8 <noreply@anthropic.com>
</commit_message>
<xml_diff>
--- a/report/Boulogeorgos_Mici.pptx
+++ b/report/Boulogeorgos_Mici.pptx
@@ -2320,6 +2320,10 @@
           </a:solidFill>
           <a:ln/>
         </p:spPr>
+        <p:txBody>
+          <a:bodyPr/>
+          <a:p/>
+        </p:txBody>
       </p:sp>
       <p:sp>
         <p:nvSpPr>
@@ -2342,6 +2346,10 @@
           </a:solidFill>
           <a:ln/>
         </p:spPr>
+        <p:txBody>
+          <a:bodyPr/>
+          <a:p/>
+        </p:txBody>
       </p:sp>
       <p:sp>
         <p:nvSpPr>
@@ -2583,7 +2591,7 @@
                 <a:ea typeface="Arial" pitchFamily="34" charset="-122"/>
                 <a:cs typeface="Arial" pitchFamily="34" charset="-120"/>
               </a:rPr>
-              <a:t>June 2026</a:t>
+              <a:t>National and Kapodistrian University of Athens  ·  MSc in Data Science and Information Technologies  ·  Supervisor: Prof. E. Manolakos  ·  June 2026</a:t>
             </a:r>
             <a:endParaRPr lang="en-US" sz="1300" dirty="0"/>
           </a:p>
@@ -7846,7 +7854,7 @@
                 <a:ea typeface="Arial" pitchFamily="34" charset="-122"/>
                 <a:cs typeface="Arial" pitchFamily="34" charset="-120"/>
               </a:rPr>
-              <a:t>Giorgos Boulogeorgos  ·  Andreas Mici    |    MLCB Team Project  ·  Communication-Aware ML for MDD  ·  June 2026</a:t>
+              <a:t>Giorgos Boulogeorgos  ·  Andreas Mici    |    MLCB Team Project · NKUA, MSc Data Science and Information Technologies  ·  Supervisor: Prof. E. Manolakos  ·  June 2026</a:t>
             </a:r>
             <a:endParaRPr lang="en-US" sz="1300" dirty="0"/>
           </a:p>

</xml_diff>